<commit_message>
P8: Mise à jour présentation PowerPoint après soutenance
</commit_message>
<xml_diff>
--- a/P8_Construisez_et_testez_une_infrastructure_de_donnees_aymeric_bailleul/_projet/ABAI_P8_00_presentation_20251127.pptx
+++ b/P8_Construisez_et_testez_une_infrastructure_de_donnees_aymeric_bailleul/_projet/ABAI_P8_00_presentation_20251127.pptx
@@ -235,7 +235,7 @@
           <a:p>
             <a:fld id="{7BD3E1E6-30BC-40E4-9813-DC590AE7B576}" type="datetimeFigureOut">
               <a:rPr lang="fr-FR" smtClean="0"/>
-              <a:t>17/12/2025</a:t>
+              <a:t>19/12/2025</a:t>
             </a:fld>
             <a:endParaRPr lang="fr-FR"/>
           </a:p>
@@ -413,7 +413,7 @@
           <a:p>
             <a:fld id="{BBA5FB3B-753F-4CD7-82D2-4F11553236B4}" type="datetimeFigureOut">
               <a:rPr lang="fr-FR" smtClean="0"/>
-              <a:t>17/12/2025</a:t>
+              <a:t>19/12/2025</a:t>
             </a:fld>
             <a:endParaRPr lang="fr-FR"/>
           </a:p>
@@ -3979,6 +3979,142 @@
           <a:bodyPr/>
           <a:lstStyle/>
           <a:p>
+            <a:r>
+              <a:rPr lang="fr-FR" dirty="0"/>
+              <a:t>Points clés à mentionner</a:t>
+            </a:r>
+          </a:p>
+          <a:p>
+            <a:endParaRPr lang="fr-FR" dirty="0"/>
+          </a:p>
+          <a:p>
+            <a:r>
+              <a:rPr lang="fr-FR" dirty="0"/>
+              <a:t>Pour </a:t>
+            </a:r>
+            <a:r>
+              <a:rPr lang="fr-FR" dirty="0" err="1"/>
+              <a:t>Ouly</a:t>
+            </a:r>
+            <a:r>
+              <a:rPr lang="fr-FR" dirty="0"/>
+              <a:t> (Data </a:t>
+            </a:r>
+            <a:r>
+              <a:rPr lang="fr-FR" dirty="0" err="1"/>
+              <a:t>Scientist</a:t>
+            </a:r>
+            <a:r>
+              <a:rPr lang="fr-FR" dirty="0"/>
+              <a:t> lead)</a:t>
+            </a:r>
+          </a:p>
+          <a:p>
+            <a:r>
+              <a:rPr lang="fr-FR" dirty="0"/>
+              <a:t>Schéma flexible : "Vous pouvez requêter MongoDB comme du JSON, pas besoin de connaître SQL"</a:t>
+            </a:r>
+          </a:p>
+          <a:p>
+            <a:r>
+              <a:rPr lang="fr-FR" dirty="0"/>
+              <a:t>Performance : "Temps de réponse &lt; 1 ms, vous ne verrez aucune latence dans vos notebooks"</a:t>
+            </a:r>
+          </a:p>
+          <a:p>
+            <a:r>
+              <a:rPr lang="fr-FR" dirty="0"/>
+              <a:t>Traçabilité : "Chaque mesure garde le nom du fichier source, vous pouvez retracer l'origine"</a:t>
+            </a:r>
+          </a:p>
+          <a:p>
+            <a:r>
+              <a:rPr lang="fr-FR" dirty="0"/>
+              <a:t>Fiabilité : "0% d'erreur, </a:t>
+            </a:r>
+            <a:r>
+              <a:rPr lang="fr-FR" dirty="0" err="1"/>
+              <a:t>unique_key</a:t>
+            </a:r>
+            <a:r>
+              <a:rPr lang="fr-FR" dirty="0"/>
+              <a:t> garantit pas de doublons dans vos modèles"</a:t>
+            </a:r>
+          </a:p>
+          <a:p>
+            <a:endParaRPr lang="fr-FR" dirty="0"/>
+          </a:p>
+          <a:p>
+            <a:r>
+              <a:rPr lang="fr-FR" dirty="0"/>
+              <a:t>Pour l'évaluateur technique</a:t>
+            </a:r>
+          </a:p>
+          <a:p>
+            <a:r>
+              <a:rPr lang="fr-FR" dirty="0"/>
+              <a:t>Architecture : "</a:t>
+            </a:r>
+            <a:r>
+              <a:rPr lang="fr-FR" dirty="0" err="1"/>
+              <a:t>Microservices</a:t>
+            </a:r>
+            <a:r>
+              <a:rPr lang="fr-FR" dirty="0"/>
+              <a:t> </a:t>
+            </a:r>
+            <a:r>
+              <a:rPr lang="fr-FR" dirty="0" err="1"/>
+              <a:t>dockerisés</a:t>
+            </a:r>
+            <a:r>
+              <a:rPr lang="fr-FR" dirty="0"/>
+              <a:t> sur ECS </a:t>
+            </a:r>
+            <a:r>
+              <a:rPr lang="fr-FR" dirty="0" err="1"/>
+              <a:t>Fargate</a:t>
+            </a:r>
+            <a:r>
+              <a:rPr lang="fr-FR" dirty="0"/>
+              <a:t>, hautement scalable"</a:t>
+            </a:r>
+          </a:p>
+          <a:p>
+            <a:r>
+              <a:rPr lang="fr-FR" dirty="0"/>
+              <a:t>Qualité : "Suite de tests automatisés (</a:t>
+            </a:r>
+            <a:r>
+              <a:rPr lang="fr-FR" dirty="0" err="1"/>
+              <a:t>pytest</a:t>
+            </a:r>
+            <a:r>
+              <a:rPr lang="fr-FR" dirty="0"/>
+              <a:t>) + validation schéma MongoDB"</a:t>
+            </a:r>
+          </a:p>
+          <a:p>
+            <a:r>
+              <a:rPr lang="fr-FR" dirty="0"/>
+              <a:t>Monitoring : "</a:t>
+            </a:r>
+            <a:r>
+              <a:rPr lang="fr-FR" dirty="0" err="1"/>
+              <a:t>CloudWatch</a:t>
+            </a:r>
+            <a:r>
+              <a:rPr lang="fr-FR" dirty="0"/>
+              <a:t> Dashboard + Benchmark de performance intégrés"</a:t>
+            </a:r>
+          </a:p>
+          <a:p>
+            <a:r>
+              <a:rPr lang="fr-FR" dirty="0"/>
+              <a:t>Coût : "Infrastructure optimisée : ~1$/jour, services manuels arrêtables pour économiser"</a:t>
+            </a:r>
+          </a:p>
+          <a:p>
             <a:endParaRPr lang="fr-FR" dirty="0"/>
           </a:p>
         </p:txBody>
@@ -4016,6 +4152,229 @@
     <p:extLst>
       <p:ext uri="{BB962C8B-B14F-4D97-AF65-F5344CB8AC3E}">
         <p14:creationId xmlns:p14="http://schemas.microsoft.com/office/powerpoint/2010/main" val="3374001414"/>
+      </p:ext>
+    </p:extLst>
+  </p:cSld>
+  <p:clrMapOvr>
+    <a:masterClrMapping/>
+  </p:clrMapOvr>
+</p:notes>
+</file>
+
+<file path=ppt/notesSlides/notesSlide17.xml><?xml version="1.0" encoding="utf-8"?>
+<p:notes xmlns:a="http://schemas.openxmlformats.org/drawingml/2006/main" xmlns:r="http://schemas.openxmlformats.org/officeDocument/2006/relationships" xmlns:p="http://schemas.openxmlformats.org/presentationml/2006/main">
+  <p:cSld>
+    <p:spTree>
+      <p:nvGrpSpPr>
+        <p:cNvPr id="1" name=""/>
+        <p:cNvGrpSpPr/>
+        <p:nvPr/>
+      </p:nvGrpSpPr>
+      <p:grpSpPr>
+        <a:xfrm>
+          <a:off x="0" y="0"/>
+          <a:ext cx="0" cy="0"/>
+          <a:chOff x="0" y="0"/>
+          <a:chExt cx="0" cy="0"/>
+        </a:xfrm>
+      </p:grpSpPr>
+      <p:sp>
+        <p:nvSpPr>
+          <p:cNvPr id="2" name="Espace réservé de l'image des diapositives 1"/>
+          <p:cNvSpPr>
+            <a:spLocks noGrp="1" noRot="1" noChangeAspect="1"/>
+          </p:cNvSpPr>
+          <p:nvPr>
+            <p:ph type="sldImg"/>
+          </p:nvPr>
+        </p:nvSpPr>
+        <p:spPr/>
+      </p:sp>
+      <p:sp>
+        <p:nvSpPr>
+          <p:cNvPr id="3" name="Espace réservé des notes 2"/>
+          <p:cNvSpPr>
+            <a:spLocks noGrp="1"/>
+          </p:cNvSpPr>
+          <p:nvPr>
+            <p:ph type="body" idx="1"/>
+          </p:nvPr>
+        </p:nvSpPr>
+        <p:spPr/>
+        <p:txBody>
+          <a:bodyPr/>
+          <a:lstStyle/>
+          <a:p>
+            <a:r>
+              <a:rPr lang="fr-FR" dirty="0"/>
+              <a:t>Points clés à mentionner</a:t>
+            </a:r>
+          </a:p>
+          <a:p>
+            <a:endParaRPr lang="fr-FR" dirty="0"/>
+          </a:p>
+          <a:p>
+            <a:r>
+              <a:rPr lang="fr-FR" dirty="0"/>
+              <a:t>Pour </a:t>
+            </a:r>
+            <a:r>
+              <a:rPr lang="fr-FR" dirty="0" err="1"/>
+              <a:t>Ouly</a:t>
+            </a:r>
+            <a:r>
+              <a:rPr lang="fr-FR" dirty="0"/>
+              <a:t> (Data </a:t>
+            </a:r>
+            <a:r>
+              <a:rPr lang="fr-FR" dirty="0" err="1"/>
+              <a:t>Scientist</a:t>
+            </a:r>
+            <a:r>
+              <a:rPr lang="fr-FR" dirty="0"/>
+              <a:t> lead)</a:t>
+            </a:r>
+          </a:p>
+          <a:p>
+            <a:r>
+              <a:rPr lang="fr-FR" dirty="0"/>
+              <a:t>Schéma flexible : "Vous pouvez requêter MongoDB comme du JSON, pas besoin de connaître SQL"</a:t>
+            </a:r>
+          </a:p>
+          <a:p>
+            <a:r>
+              <a:rPr lang="fr-FR" dirty="0"/>
+              <a:t>Performance : "Temps de réponse &lt; 1 ms, vous ne verrez aucune latence dans vos notebooks"</a:t>
+            </a:r>
+          </a:p>
+          <a:p>
+            <a:r>
+              <a:rPr lang="fr-FR" dirty="0"/>
+              <a:t>Traçabilité : "Chaque mesure garde le nom du fichier source, vous pouvez retracer l'origine"</a:t>
+            </a:r>
+          </a:p>
+          <a:p>
+            <a:r>
+              <a:rPr lang="fr-FR" dirty="0"/>
+              <a:t>Fiabilité : "0% d'erreur, </a:t>
+            </a:r>
+            <a:r>
+              <a:rPr lang="fr-FR" dirty="0" err="1"/>
+              <a:t>unique_key</a:t>
+            </a:r>
+            <a:r>
+              <a:rPr lang="fr-FR" dirty="0"/>
+              <a:t> garantit pas de doublons dans vos modèles"</a:t>
+            </a:r>
+          </a:p>
+          <a:p>
+            <a:endParaRPr lang="fr-FR" dirty="0"/>
+          </a:p>
+          <a:p>
+            <a:r>
+              <a:rPr lang="fr-FR" dirty="0"/>
+              <a:t>Pour l'évaluateur technique</a:t>
+            </a:r>
+          </a:p>
+          <a:p>
+            <a:r>
+              <a:rPr lang="fr-FR" dirty="0"/>
+              <a:t>Architecture : "</a:t>
+            </a:r>
+            <a:r>
+              <a:rPr lang="fr-FR" dirty="0" err="1"/>
+              <a:t>Microservices</a:t>
+            </a:r>
+            <a:r>
+              <a:rPr lang="fr-FR" dirty="0"/>
+              <a:t> </a:t>
+            </a:r>
+            <a:r>
+              <a:rPr lang="fr-FR" dirty="0" err="1"/>
+              <a:t>dockerisés</a:t>
+            </a:r>
+            <a:r>
+              <a:rPr lang="fr-FR" dirty="0"/>
+              <a:t> sur ECS </a:t>
+            </a:r>
+            <a:r>
+              <a:rPr lang="fr-FR" dirty="0" err="1"/>
+              <a:t>Fargate</a:t>
+            </a:r>
+            <a:r>
+              <a:rPr lang="fr-FR" dirty="0"/>
+              <a:t>, hautement scalable"</a:t>
+            </a:r>
+          </a:p>
+          <a:p>
+            <a:r>
+              <a:rPr lang="fr-FR" dirty="0"/>
+              <a:t>Qualité : "Suite de tests automatisés (</a:t>
+            </a:r>
+            <a:r>
+              <a:rPr lang="fr-FR" dirty="0" err="1"/>
+              <a:t>pytest</a:t>
+            </a:r>
+            <a:r>
+              <a:rPr lang="fr-FR" dirty="0"/>
+              <a:t>) + validation schéma MongoDB"</a:t>
+            </a:r>
+          </a:p>
+          <a:p>
+            <a:r>
+              <a:rPr lang="fr-FR" dirty="0"/>
+              <a:t>Monitoring : "</a:t>
+            </a:r>
+            <a:r>
+              <a:rPr lang="fr-FR" dirty="0" err="1"/>
+              <a:t>CloudWatch</a:t>
+            </a:r>
+            <a:r>
+              <a:rPr lang="fr-FR" dirty="0"/>
+              <a:t> Dashboard + Benchmark de performance intégrés"</a:t>
+            </a:r>
+          </a:p>
+          <a:p>
+            <a:r>
+              <a:rPr lang="fr-FR" dirty="0"/>
+              <a:t>Coût : "Infrastructure optimisée : ~1$/jour, services manuels arrêtables pour économiser"</a:t>
+            </a:r>
+          </a:p>
+          <a:p>
+            <a:endParaRPr lang="fr-FR" dirty="0"/>
+          </a:p>
+          <a:p>
+            <a:endParaRPr lang="fr-FR" dirty="0"/>
+          </a:p>
+        </p:txBody>
+      </p:sp>
+      <p:sp>
+        <p:nvSpPr>
+          <p:cNvPr id="4" name="Espace réservé du numéro de diapositive 3"/>
+          <p:cNvSpPr>
+            <a:spLocks noGrp="1"/>
+          </p:cNvSpPr>
+          <p:nvPr>
+            <p:ph type="sldNum" sz="quarter" idx="5"/>
+          </p:nvPr>
+        </p:nvSpPr>
+        <p:spPr/>
+        <p:txBody>
+          <a:bodyPr/>
+          <a:lstStyle/>
+          <a:p>
+            <a:fld id="{9FF71DC9-7783-45BF-A97C-2CB98E86449F}" type="slidenum">
+              <a:rPr lang="fr-FR" smtClean="0"/>
+              <a:t>24</a:t>
+            </a:fld>
+            <a:endParaRPr lang="fr-FR"/>
+          </a:p>
+        </p:txBody>
+      </p:sp>
+    </p:spTree>
+    <p:extLst>
+      <p:ext uri="{BB962C8B-B14F-4D97-AF65-F5344CB8AC3E}">
+        <p14:creationId xmlns:p14="http://schemas.microsoft.com/office/powerpoint/2010/main" val="2255865638"/>
       </p:ext>
     </p:extLst>
   </p:cSld>
@@ -5133,7 +5492,7 @@
           <a:p>
             <a:fld id="{731280DA-2C14-42F1-B8EA-2EBBD063A98A}" type="datetime1">
               <a:rPr lang="en-US" smtClean="0"/>
-              <a:t>12/17/2025</a:t>
+              <a:t>12/19/2025</a:t>
             </a:fld>
             <a:endParaRPr lang="en-US" dirty="0"/>
           </a:p>
@@ -5474,7 +5833,7 @@
           <a:p>
             <a:fld id="{B42648DC-6039-4A4D-AA6A-3710C562B974}" type="datetime1">
               <a:rPr lang="en-US" smtClean="0"/>
-              <a:t>12/17/2025</a:t>
+              <a:t>12/19/2025</a:t>
             </a:fld>
             <a:endParaRPr lang="en-US" dirty="0"/>
           </a:p>
@@ -5878,7 +6237,7 @@
           <a:p>
             <a:fld id="{E82F32CF-C543-45C5-BE80-DE04628EDC5D}" type="datetime1">
               <a:rPr lang="en-US" smtClean="0"/>
-              <a:t>12/17/2025</a:t>
+              <a:t>12/19/2025</a:t>
             </a:fld>
             <a:endParaRPr lang="en-US" dirty="0"/>
           </a:p>
@@ -6217,7 +6576,7 @@
           <a:p>
             <a:fld id="{F4FDD754-58C2-4486-A35C-A2DA81E55520}" type="datetime1">
               <a:rPr lang="en-US" smtClean="0"/>
-              <a:t>12/17/2025</a:t>
+              <a:t>12/19/2025</a:t>
             </a:fld>
             <a:endParaRPr lang="en-US" dirty="0"/>
           </a:p>
@@ -6540,7 +6899,7 @@
           <a:p>
             <a:fld id="{4E6B134D-C116-41A5-B198-38FFE3BB2C48}" type="datetime1">
               <a:rPr lang="en-US" smtClean="0"/>
-              <a:t>12/17/2025</a:t>
+              <a:t>12/19/2025</a:t>
             </a:fld>
             <a:endParaRPr lang="en-US" dirty="0"/>
           </a:p>
@@ -6939,7 +7298,7 @@
           <a:p>
             <a:fld id="{7D060BD6-78E1-4AC5-AF54-878DA3A98B08}" type="datetime1">
               <a:rPr lang="en-US" smtClean="0"/>
-              <a:t>12/17/2025</a:t>
+              <a:t>12/19/2025</a:t>
             </a:fld>
             <a:endParaRPr lang="en-US" dirty="0"/>
           </a:p>
@@ -7199,7 +7558,7 @@
           <a:p>
             <a:fld id="{25586FC5-ACDF-46FE-80C5-09A060A2CFB7}" type="datetime1">
               <a:rPr lang="en-US" smtClean="0"/>
-              <a:t>12/17/2025</a:t>
+              <a:t>12/19/2025</a:t>
             </a:fld>
             <a:endParaRPr lang="en-US" dirty="0"/>
           </a:p>
@@ -7464,7 +7823,7 @@
           <a:p>
             <a:fld id="{6381086A-1052-4CBF-A9D1-AE6558B0D70F}" type="datetime1">
               <a:rPr lang="en-US" smtClean="0"/>
-              <a:t>12/17/2025</a:t>
+              <a:t>12/19/2025</a:t>
             </a:fld>
             <a:endParaRPr lang="en-US" dirty="0"/>
           </a:p>
@@ -7729,7 +8088,7 @@
           <a:p>
             <a:fld id="{9E206E72-7F42-42AD-A66F-B4FC45441BBF}" type="datetime1">
               <a:rPr lang="en-US" smtClean="0"/>
-              <a:t>12/17/2025</a:t>
+              <a:t>12/19/2025</a:t>
             </a:fld>
             <a:endParaRPr lang="en-US" dirty="0"/>
           </a:p>
@@ -8061,7 +8420,7 @@
           <a:p>
             <a:fld id="{6E0F75D3-0A01-4A88-B8FB-5DE8D5ABA152}" type="datetime1">
               <a:rPr lang="en-US" smtClean="0"/>
-              <a:t>12/17/2025</a:t>
+              <a:t>12/19/2025</a:t>
             </a:fld>
             <a:endParaRPr lang="en-US" dirty="0"/>
           </a:p>
@@ -8387,7 +8746,7 @@
           <a:p>
             <a:fld id="{7B3C6D75-ABBE-4E19-B3B1-11237CE93E6E}" type="datetime1">
               <a:rPr lang="en-US" smtClean="0"/>
-              <a:t>12/17/2025</a:t>
+              <a:t>12/19/2025</a:t>
             </a:fld>
             <a:endParaRPr lang="en-US" dirty="0"/>
           </a:p>
@@ -8847,7 +9206,7 @@
           <a:p>
             <a:fld id="{DE39FF8B-328C-407F-945B-0A37ECCD5810}" type="datetime1">
               <a:rPr lang="en-US" smtClean="0"/>
-              <a:t>12/17/2025</a:t>
+              <a:t>12/19/2025</a:t>
             </a:fld>
             <a:endParaRPr lang="en-US" dirty="0"/>
           </a:p>
@@ -9055,7 +9414,7 @@
           <a:p>
             <a:fld id="{CBFF86E2-6F3F-434F-A444-617AE3899653}" type="datetime1">
               <a:rPr lang="en-US" smtClean="0"/>
-              <a:t>12/17/2025</a:t>
+              <a:t>12/19/2025</a:t>
             </a:fld>
             <a:endParaRPr lang="en-US" dirty="0"/>
           </a:p>
@@ -9235,7 +9594,7 @@
           <a:p>
             <a:fld id="{6237684A-AD06-4EBB-9234-7B0C6B636787}" type="datetime1">
               <a:rPr lang="en-US" smtClean="0"/>
-              <a:t>12/17/2025</a:t>
+              <a:t>12/19/2025</a:t>
             </a:fld>
             <a:endParaRPr lang="en-US" dirty="0"/>
           </a:p>
@@ -9571,7 +9930,7 @@
           <a:p>
             <a:fld id="{51C57D90-09F8-44DD-88F8-88949A515FF4}" type="datetime1">
               <a:rPr lang="en-US" smtClean="0"/>
-              <a:t>12/17/2025</a:t>
+              <a:t>12/19/2025</a:t>
             </a:fld>
             <a:endParaRPr lang="en-US" dirty="0"/>
           </a:p>
@@ -9919,7 +10278,7 @@
           <a:p>
             <a:fld id="{10E7858E-8B67-403C-8D21-98816AC951BE}" type="datetime1">
               <a:rPr lang="en-US" smtClean="0"/>
-              <a:t>12/17/2025</a:t>
+              <a:t>12/19/2025</a:t>
             </a:fld>
             <a:endParaRPr lang="en-US" dirty="0"/>
           </a:p>
@@ -12214,7 +12573,7 @@
           <a:p>
             <a:fld id="{AF3DBE66-239A-4076-83CF-EF76E4714144}" type="datetime1">
               <a:rPr lang="en-US" smtClean="0"/>
-              <a:t>12/17/2025</a:t>
+              <a:t>12/19/2025</a:t>
             </a:fld>
             <a:endParaRPr lang="en-US" dirty="0"/>
           </a:p>
@@ -22065,14 +22424,14 @@
           <p:nvPr>
             <p:extLst>
               <p:ext uri="{D42A27DB-BD31-4B8C-83A1-F6EECF244321}">
-                <p14:modId xmlns:p14="http://schemas.microsoft.com/office/powerpoint/2010/main" val="167541132"/>
+                <p14:modId xmlns:p14="http://schemas.microsoft.com/office/powerpoint/2010/main" val="1395163431"/>
               </p:ext>
             </p:extLst>
           </p:nvPr>
         </p:nvGraphicFramePr>
         <p:xfrm>
-          <a:off x="1461196" y="4272784"/>
-          <a:ext cx="9593259" cy="1122045"/>
+          <a:off x="1261994" y="4280869"/>
+          <a:ext cx="9991664" cy="993921"/>
         </p:xfrm>
         <a:graphic>
           <a:graphicData uri="http://schemas.openxmlformats.org/drawingml/2006/table">
@@ -22102,7 +22461,7 @@
                     </a:ext>
                   </a:extLst>
                 </a:gridCol>
-                <a:gridCol w="3626046">
+                <a:gridCol w="4024451">
                   <a:extLst>
                     <a:ext uri="{9D8B030D-6E8A-4147-A177-3AD203B41FA5}">
                       <a16:colId xmlns:a16="http://schemas.microsoft.com/office/drawing/2014/main" val="965470589"/>

</xml_diff>